<commit_message>
Align final submission materials with official format
</commit_message>
<xml_diff>
--- a/docs/submission/刃知-AgentTeams-初赛方案.pptx
+++ b/docs/submission/刃知-AgentTeams-初赛方案.pptx
@@ -2,32 +2,32 @@
 <file path=ppt/presentation.xml><?xml version="1.0" encoding="utf-8"?>
 <p:presentation xmlns:p="http://schemas.openxmlformats.org/presentationml/2006/main">
   <p:sldMasterIdLst>
-    <p:sldMasterId xmlns:r="http://schemas.openxmlformats.org/officeDocument/2006/relationships" id="2147483648" r:id="R8dd70e4088414c03"/>
-    <p:sldMasterId xmlns:r="http://schemas.openxmlformats.org/officeDocument/2006/relationships" id="2147483650" r:id="R9c338f9a6f6e4d1f"/>
+    <p:sldMasterId xmlns:r="http://schemas.openxmlformats.org/officeDocument/2006/relationships" id="2147483648" r:id="R936521bb6e814ec3"/>
+    <p:sldMasterId xmlns:r="http://schemas.openxmlformats.org/officeDocument/2006/relationships" id="2147483650" r:id="R5a44094251134017"/>
   </p:sldMasterIdLst>
   <p:notesMasterIdLst>
-    <p:notesMasterId xmlns:r="http://schemas.openxmlformats.org/officeDocument/2006/relationships" r:id="Rc01b385c0be9472f"/>
+    <p:notesMasterId xmlns:r="http://schemas.openxmlformats.org/officeDocument/2006/relationships" r:id="Rd83a3bcbb35348fe"/>
   </p:notesMasterIdLst>
   <p:sldIdLst>
-    <p:sldId xmlns:r="http://schemas.openxmlformats.org/officeDocument/2006/relationships" id="256" r:id="Rf1e7c5c0dcad48b0"/>
-    <p:sldId xmlns:r="http://schemas.openxmlformats.org/officeDocument/2006/relationships" id="257" r:id="Re6d772f8d6aa4f24"/>
-    <p:sldId xmlns:r="http://schemas.openxmlformats.org/officeDocument/2006/relationships" id="258" r:id="Rdf9f95cd462a42e5"/>
-    <p:sldId xmlns:r="http://schemas.openxmlformats.org/officeDocument/2006/relationships" id="259" r:id="Rce4758f3d47645a1"/>
-    <p:sldId xmlns:r="http://schemas.openxmlformats.org/officeDocument/2006/relationships" id="260" r:id="Rcad303b9e7a24afe"/>
-    <p:sldId xmlns:r="http://schemas.openxmlformats.org/officeDocument/2006/relationships" id="261" r:id="Rad5262d3f47e4663"/>
-    <p:sldId xmlns:r="http://schemas.openxmlformats.org/officeDocument/2006/relationships" id="262" r:id="Rbbc35d7d6942470f"/>
-    <p:sldId xmlns:r="http://schemas.openxmlformats.org/officeDocument/2006/relationships" id="263" r:id="Rfcb274ed173e49f4"/>
-    <p:sldId xmlns:r="http://schemas.openxmlformats.org/officeDocument/2006/relationships" id="264" r:id="R32932a127fbb4bd9"/>
-    <p:sldId xmlns:r="http://schemas.openxmlformats.org/officeDocument/2006/relationships" id="265" r:id="Rd7b82b5115184512"/>
-    <p:sldId xmlns:r="http://schemas.openxmlformats.org/officeDocument/2006/relationships" id="266" r:id="R1f374436ae204762"/>
-    <p:sldId xmlns:r="http://schemas.openxmlformats.org/officeDocument/2006/relationships" id="267" r:id="Rdb4eb9db59ac41f5"/>
-    <p:sldId xmlns:r="http://schemas.openxmlformats.org/officeDocument/2006/relationships" id="268" r:id="Rafafa74575234abc"/>
-    <p:sldId xmlns:r="http://schemas.openxmlformats.org/officeDocument/2006/relationships" id="269" r:id="R40aa6275c4704013"/>
-    <p:sldId xmlns:r="http://schemas.openxmlformats.org/officeDocument/2006/relationships" id="270" r:id="R0c87268043664985"/>
-    <p:sldId xmlns:r="http://schemas.openxmlformats.org/officeDocument/2006/relationships" id="271" r:id="R76ad1d82dba44082"/>
-    <p:sldId xmlns:r="http://schemas.openxmlformats.org/officeDocument/2006/relationships" id="272" r:id="R7df9d717c1cf4c17"/>
-    <p:sldId xmlns:r="http://schemas.openxmlformats.org/officeDocument/2006/relationships" id="273" r:id="R7b8035d2f5384b6e"/>
-    <p:sldId xmlns:r="http://schemas.openxmlformats.org/officeDocument/2006/relationships" id="274" r:id="R7bb9cc013e904d7c"/>
+    <p:sldId xmlns:r="http://schemas.openxmlformats.org/officeDocument/2006/relationships" id="256" r:id="Rc522eb2cee2b4b10"/>
+    <p:sldId xmlns:r="http://schemas.openxmlformats.org/officeDocument/2006/relationships" id="257" r:id="Rf96178ae96074393"/>
+    <p:sldId xmlns:r="http://schemas.openxmlformats.org/officeDocument/2006/relationships" id="258" r:id="R29ca8e35f2494f71"/>
+    <p:sldId xmlns:r="http://schemas.openxmlformats.org/officeDocument/2006/relationships" id="259" r:id="R996407049c4742be"/>
+    <p:sldId xmlns:r="http://schemas.openxmlformats.org/officeDocument/2006/relationships" id="260" r:id="Rc7b6e053666946f8"/>
+    <p:sldId xmlns:r="http://schemas.openxmlformats.org/officeDocument/2006/relationships" id="261" r:id="R2cea6263330a40d9"/>
+    <p:sldId xmlns:r="http://schemas.openxmlformats.org/officeDocument/2006/relationships" id="262" r:id="R4b850bb937e74851"/>
+    <p:sldId xmlns:r="http://schemas.openxmlformats.org/officeDocument/2006/relationships" id="263" r:id="Rc91f08ff365f4ddb"/>
+    <p:sldId xmlns:r="http://schemas.openxmlformats.org/officeDocument/2006/relationships" id="264" r:id="R3dfd1bba46524e39"/>
+    <p:sldId xmlns:r="http://schemas.openxmlformats.org/officeDocument/2006/relationships" id="265" r:id="Rc3a19201c891479f"/>
+    <p:sldId xmlns:r="http://schemas.openxmlformats.org/officeDocument/2006/relationships" id="266" r:id="R53eb91e7ddf44119"/>
+    <p:sldId xmlns:r="http://schemas.openxmlformats.org/officeDocument/2006/relationships" id="267" r:id="R42ebed8d439b44f2"/>
+    <p:sldId xmlns:r="http://schemas.openxmlformats.org/officeDocument/2006/relationships" id="268" r:id="Radc40ef08c88463f"/>
+    <p:sldId xmlns:r="http://schemas.openxmlformats.org/officeDocument/2006/relationships" id="269" r:id="Rcc66c2ca61694f66"/>
+    <p:sldId xmlns:r="http://schemas.openxmlformats.org/officeDocument/2006/relationships" id="270" r:id="Ref8b7e3125a44885"/>
+    <p:sldId xmlns:r="http://schemas.openxmlformats.org/officeDocument/2006/relationships" id="271" r:id="R201909b794d74148"/>
+    <p:sldId xmlns:r="http://schemas.openxmlformats.org/officeDocument/2006/relationships" id="272" r:id="R0bbe3a8cdbd0459b"/>
+    <p:sldId xmlns:r="http://schemas.openxmlformats.org/officeDocument/2006/relationships" id="273" r:id="Rc450ebf0390c472e"/>
+    <p:sldId xmlns:r="http://schemas.openxmlformats.org/officeDocument/2006/relationships" id="274" r:id="Rd31d0648de904426"/>
   </p:sldIdLst>
   <p:sldSz cx="12192000" cy="6858000"/>
   <p:notesSz cx="6858000" cy="9144000"/>
@@ -681,7 +681,25 @@
           </a:p>
           <a:p xmlns:a="http://schemas.openxmlformats.org/drawingml/2006/main">
             <a:r>
-              <a:t>- F:/Toolwear_agent/toolwear_agent_app/docs/assets/demo/05-approved-pipeline.png</a:t>
+              <a:t>- docs/skill-manifest.md</a:t>
+            </a:r>
+            <a:endParaRPr/>
+          </a:p>
+          <a:p xmlns:a="http://schemas.openxmlformats.org/drawingml/2006/main">
+            <a:r>
+              <a:t>- toolwear_agent/agents/catalog.py</a:t>
+            </a:r>
+            <a:endParaRPr/>
+          </a:p>
+          <a:p xmlns:a="http://schemas.openxmlformats.org/drawingml/2006/main">
+            <a:r>
+              <a:t>- docs/evidence/agentteams_e2e_final_manifest.json</a:t>
+            </a:r>
+            <a:endParaRPr/>
+          </a:p>
+          <a:p xmlns:a="http://schemas.openxmlformats.org/drawingml/2006/main">
+            <a:r>
+              <a:t>- docs/assets/demo/13-skill-registry-evidence.png</a:t>
             </a:r>
             <a:endParaRPr/>
           </a:p>
@@ -877,25 +895,25 @@
           </a:p>
           <a:p xmlns:a="http://schemas.openxmlformats.org/drawingml/2006/main">
             <a:r>
-              <a:t>- F:/Toolwear_agent/toolwear_agent_app/docs/assets/demo/04-llm-candidates.png</a:t>
+              <a:t>- docs/assets/demo/04-llm-candidates.png</a:t>
             </a:r>
             <a:endParaRPr/>
           </a:p>
           <a:p xmlns:a="http://schemas.openxmlformats.org/drawingml/2006/main">
             <a:r>
-              <a:t>- F:/Toolwear_agent/toolwear_agent_app/docs/assets/demo/06-training-result.png</a:t>
+              <a:t>- docs/assets/demo/06-training-result.png</a:t>
             </a:r>
             <a:endParaRPr/>
           </a:p>
           <a:p xmlns:a="http://schemas.openxmlformats.org/drawingml/2006/main">
             <a:r>
-              <a:t>- F:/Toolwear_agent/toolwear_agent_app/docs/assets/demo/07-evaluation-metrics.png</a:t>
+              <a:t>- docs/assets/demo/07-evaluation-metrics.png</a:t>
             </a:r>
             <a:endParaRPr/>
           </a:p>
           <a:p xmlns:a="http://schemas.openxmlformats.org/drawingml/2006/main">
             <a:r>
-              <a:t>- F:/Toolwear_agent/toolwear_agent_app/docs/assets/demo/08-evaluation-diagnosis.png</a:t>
+              <a:t>- docs/assets/demo/08-evaluation-diagnosis.png</a:t>
             </a:r>
             <a:endParaRPr/>
           </a:p>
@@ -1281,13 +1299,13 @@
           </a:p>
           <a:p xmlns:a="http://schemas.openxmlformats.org/drawingml/2006/main">
             <a:r>
-              <a:t>- F:/Toolwear_agent/toolwear_agent_app/docs/assets/demo/09-decision-archive.png</a:t>
+              <a:t>- docs/assets/demo/09-decision-archive.png</a:t>
             </a:r>
             <a:endParaRPr/>
           </a:p>
           <a:p xmlns:a="http://schemas.openxmlformats.org/drawingml/2006/main">
             <a:r>
-              <a:t>- F:/Toolwear_agent/toolwear_agent_app/docs/assets/demo/10-evidence-timeline.png</a:t>
+              <a:t>- docs/assets/demo/10-evidence-timeline.png</a:t>
             </a:r>
             <a:endParaRPr/>
           </a:p>
@@ -1573,7 +1591,7 @@
           </a:p>
           <a:p xmlns:a="http://schemas.openxmlformats.org/drawingml/2006/main">
             <a:r>
-              <a:t>- F:/Toolwear_agent/toolwear_agent_app/docs/submission/初赛作品简介.md</a:t>
+              <a:t>- docs/submission/初赛作品简介.md</a:t>
             </a:r>
             <a:endParaRPr/>
           </a:p>
@@ -1853,12 +1871,12 @@
           </a:p>
           <a:p xmlns:a="http://schemas.openxmlformats.org/drawingml/2006/main">
             <a:r>
-              <a:t>- F:/Toolwear_agent/toolwear_agent_app/docs/assets/demo/01-new-experiment.png</a:t>
-            </a:r>
-          </a:p>
-          <a:p xmlns:a="http://schemas.openxmlformats.org/drawingml/2006/main">
-            <a:r>
-              <a:t>- F:/Toolwear_agent/toolwear_agent_app/docs/assets/demo/03-data-prepared.png</a:t>
+              <a:t>- docs/assets/demo/01-new-experiment.png</a:t>
+            </a:r>
+          </a:p>
+          <a:p xmlns:a="http://schemas.openxmlformats.org/drawingml/2006/main">
+            <a:r>
+              <a:t>- docs/assets/demo/03-data-prepared.png</a:t>
             </a:r>
           </a:p>
         </p:txBody>
@@ -2047,7 +2065,7 @@
           </a:p>
           <a:p xmlns:a="http://schemas.openxmlformats.org/drawingml/2006/main">
             <a:r>
-              <a:t>- F:/Toolwear_agent/toolwear_agent_app/docs/assets/demo/02-experiment-defined.png</a:t>
+              <a:t>- docs/assets/demo/02-experiment-defined.png</a:t>
             </a:r>
             <a:endParaRPr/>
           </a:p>
@@ -2243,19 +2261,19 @@
           </a:p>
           <a:p xmlns:a="http://schemas.openxmlformats.org/drawingml/2006/main">
             <a:r>
-              <a:t>- F:/Toolwear_agent/toolwear_agent_app/docs/assets/demo/11-agent-collaboration.png</a:t>
+              <a:t>- docs/assets/demo/11-agent-collaboration.png</a:t>
             </a:r>
             <a:endParaRPr/>
           </a:p>
           <a:p xmlns:a="http://schemas.openxmlformats.org/drawingml/2006/main">
             <a:r>
-              <a:t>- F:/Toolwear_agent/toolwear_agent_app/docs/assets/demo/12-element-agentteams-team.png</a:t>
+              <a:t>- docs/assets/demo/12-element-agentteams-team.png</a:t>
             </a:r>
             <a:endParaRPr/>
           </a:p>
           <a:p xmlns:a="http://schemas.openxmlformats.org/drawingml/2006/main">
             <a:r>
-              <a:t>- D:/AI_infra/agentteams/evidence/agt-e2e-final-20260815174832/agentteams_e2e_report.md</a:t>
+              <a:t>- docs/evidence/agentteams_e2e_final_manifest.json</a:t>
             </a:r>
             <a:endParaRPr/>
           </a:p>
@@ -2351,7 +2369,7 @@
   </p:cSld>
   <p:clrMap bg1="lt1" tx1="dk1" bg2="lt2" tx2="dk2" accent1="accent1" accent2="accent2" accent3="accent3" accent4="accent4" accent5="accent5" accent6="accent6" hlink="hlink" folHlink="folHlink"/>
   <p:sldLayoutIdLst>
-    <p:sldLayoutId xmlns:r="http://schemas.openxmlformats.org/officeDocument/2006/relationships" id="2147483649" r:id="R735419c96fc7442f"/>
+    <p:sldLayoutId xmlns:r="http://schemas.openxmlformats.org/officeDocument/2006/relationships" id="2147483649" r:id="R2f7973ccb2664608"/>
   </p:sldLayoutIdLst>
   <p:hf sldNum="0" hdr="0" ftr="0" dt="0"/>
   <p:txStyles>
@@ -2634,7 +2652,7 @@
   </p:cSld>
   <p:clrMap bg1="lt1" tx1="dk1" bg2="lt2" tx2="dk2" accent1="accent1" accent2="accent2" accent3="accent3" accent4="accent4" accent5="accent5" accent6="accent6" hlink="hlink" folHlink="folHlink"/>
   <p:sldLayoutIdLst>
-    <p:sldLayoutId xmlns:r="http://schemas.openxmlformats.org/officeDocument/2006/relationships" id="2147483651" r:id="Rbfad9f1f72ed4bc8"/>
+    <p:sldLayoutId xmlns:r="http://schemas.openxmlformats.org/officeDocument/2006/relationships" id="2147483651" r:id="R475cc53942494aca"/>
   </p:sldLayoutIdLst>
   <p:hf sldNum="0" hdr="0" ftr="0" dt="0"/>
   <p:txStyles>
@@ -4295,7 +4313,7 @@
                 <a:ea typeface="微软雅黑"/>
                 <a:cs typeface="微软雅黑"/>
               </a:rPr>
-              <a:t>每个 Skill 定义用途、输入输出、触发、依赖、失败处理、安全边界、复用方式和协作 Agent；审批后冻结 Pipeline revision。</a:t>
+              <a:t>每个 Skill 都有 Owner、SKILL.md、client.py、输入/输出 JSON Schema、权限白名单、失败处理和 Evidence 审计；下图来自项目真实 Manifest 与脱敏调用记录。</a:t>
             </a:r>
             <a:endParaRPr>
               <a:latin typeface="微软雅黑"/>
@@ -4314,7 +4332,7 @@
           <p:nvPr/>
         </p:nvPicPr>
         <p:blipFill>
-          <a:blip xmlns:r="http://schemas.openxmlformats.org/officeDocument/2006/relationships" xmlns:a="http://schemas.openxmlformats.org/drawingml/2006/main" r:embed="Rdc4ab8a7a81f436a"/>
+          <a:blip xmlns:r="http://schemas.openxmlformats.org/officeDocument/2006/relationships" xmlns:a="http://schemas.openxmlformats.org/drawingml/2006/main" r:embed="R6865f36a7f0540e4"/>
           <a:stretch xmlns:a="http://schemas.openxmlformats.org/drawingml/2006/main">
             <a:fillRect l="0" t="0" r="0" b="0"/>
           </a:stretch>
@@ -4490,7 +4508,7 @@
                 <a:ea typeface="微软雅黑"/>
                 <a:cs typeface="微软雅黑"/>
               </a:rPr>
-              <a:t>工程落地、运行验证与安全可审计</a:t>
+              <a:t>可行性、异常分支与安全边界均可验证</a:t>
             </a:r>
             <a:endParaRPr sz="2900"/>
           </a:p>
@@ -4874,7 +4892,7 @@
           <p:nvPr/>
         </p:nvPicPr>
         <p:blipFill>
-          <a:blip xmlns:r="http://schemas.openxmlformats.org/officeDocument/2006/relationships" xmlns:a="http://schemas.openxmlformats.org/drawingml/2006/main" r:embed="R2ef9001d2b2c422f"/>
+          <a:blip xmlns:r="http://schemas.openxmlformats.org/officeDocument/2006/relationships" xmlns:a="http://schemas.openxmlformats.org/drawingml/2006/main" r:embed="Rc76264d036d74658"/>
           <a:stretch xmlns:a="http://schemas.openxmlformats.org/drawingml/2006/main">
             <a:fillRect l="0" t="0" r="0" b="0"/>
           </a:stretch>
@@ -4898,7 +4916,7 @@
           <p:nvPr/>
         </p:nvPicPr>
         <p:blipFill>
-          <a:blip xmlns:r="http://schemas.openxmlformats.org/officeDocument/2006/relationships" xmlns:a="http://schemas.openxmlformats.org/drawingml/2006/main" r:embed="R68405b9464344c75"/>
+          <a:blip xmlns:r="http://schemas.openxmlformats.org/officeDocument/2006/relationships" xmlns:a="http://schemas.openxmlformats.org/drawingml/2006/main" r:embed="Rdecdbe1b3f254bf8"/>
           <a:stretch xmlns:a="http://schemas.openxmlformats.org/drawingml/2006/main">
             <a:fillRect l="0" t="0" r="0" b="0"/>
           </a:stretch>
@@ -4922,7 +4940,7 @@
           <p:nvPr/>
         </p:nvPicPr>
         <p:blipFill>
-          <a:blip xmlns:r="http://schemas.openxmlformats.org/officeDocument/2006/relationships" xmlns:a="http://schemas.openxmlformats.org/drawingml/2006/main" r:embed="R560e1817cd3e4515"/>
+          <a:blip xmlns:r="http://schemas.openxmlformats.org/officeDocument/2006/relationships" xmlns:a="http://schemas.openxmlformats.org/drawingml/2006/main" r:embed="R76222fa64f444262"/>
           <a:stretch xmlns:a="http://schemas.openxmlformats.org/drawingml/2006/main">
             <a:fillRect l="0" t="0" r="0" b="0"/>
           </a:stretch>
@@ -4946,7 +4964,7 @@
           <p:nvPr/>
         </p:nvPicPr>
         <p:blipFill>
-          <a:blip xmlns:r="http://schemas.openxmlformats.org/officeDocument/2006/relationships" xmlns:a="http://schemas.openxmlformats.org/drawingml/2006/main" r:embed="Re54a2774c9004807"/>
+          <a:blip xmlns:r="http://schemas.openxmlformats.org/officeDocument/2006/relationships" xmlns:a="http://schemas.openxmlformats.org/drawingml/2006/main" r:embed="R412d44c3191d48dd"/>
           <a:stretch xmlns:a="http://schemas.openxmlformats.org/drawingml/2006/main">
             <a:fillRect l="0" t="0" r="0" b="0"/>
           </a:stretch>
@@ -5587,7 +5605,7 @@
                 <a:ea typeface="微软雅黑"/>
                 <a:cs typeface="微软雅黑"/>
               </a:rPr>
-              <a:t>十个 Skill、Registry、API 契约、代码、测试和启动脚本</a:t>
+              <a:t>十个 Skill、Registry、API 契约与测试；提交包含入口、依赖、配置、样例和证据</a:t>
             </a:r>
             <a:endParaRPr>
               <a:latin typeface="微软雅黑"/>
@@ -5721,31 +5739,7 @@
                 <a:ea typeface="微软雅黑"/>
                 <a:cs typeface="微软雅黑"/>
               </a:rPr>
-              <a:t>提供 README、完整使用流程和脱敏样例</a:t>
-            </a:r>
-            <a:endParaRPr>
-              <a:latin typeface="微软雅黑"/>
-              <a:ea typeface="微软雅黑"/>
-              <a:cs typeface="微软雅黑"/>
-            </a:endParaRPr>
-          </a:p>
-          <a:p xmlns:a="http://schemas.openxmlformats.org/drawingml/2006/main">
-            <a:pPr marL="285750" indent="-285750" algn="l">
-              <a:lnSpc>
-                <a:spcPct val="150000"/>
-              </a:lnSpc>
-              <a:buClrTx/>
-              <a:buSzTx/>
-              <a:buFont typeface="Arial"/>
-              <a:buChar char="•"/>
-            </a:pPr>
-            <a:r>
-              <a:rPr>
-                <a:latin typeface="微软雅黑"/>
-                <a:ea typeface="微软雅黑"/>
-                <a:cs typeface="微软雅黑"/>
-              </a:rPr>
-              <a:t>可迁移到轴承、齿轮和其他多通道时序任务</a:t>
+              <a:t>README 给出完整流程；Adapter 可迁移到轴承、齿轮等时序任务</a:t>
             </a:r>
             <a:endParaRPr>
               <a:latin typeface="微软雅黑"/>
@@ -6139,7 +6133,7 @@
           <p:nvPr/>
         </p:nvPicPr>
         <p:blipFill>
-          <a:blip xmlns:r="http://schemas.openxmlformats.org/officeDocument/2006/relationships" xmlns:a="http://schemas.openxmlformats.org/drawingml/2006/main" r:embed="Rc9748a3adb274a4a"/>
+          <a:blip xmlns:r="http://schemas.openxmlformats.org/officeDocument/2006/relationships" xmlns:a="http://schemas.openxmlformats.org/drawingml/2006/main" r:embed="R338013f482784ce4"/>
           <a:stretch xmlns:a="http://schemas.openxmlformats.org/drawingml/2006/main">
             <a:fillRect l="0" t="0" r="0" b="0"/>
           </a:stretch>
@@ -6163,7 +6157,7 @@
           <p:nvPr/>
         </p:nvPicPr>
         <p:blipFill>
-          <a:blip xmlns:r="http://schemas.openxmlformats.org/officeDocument/2006/relationships" xmlns:a="http://schemas.openxmlformats.org/drawingml/2006/main" r:embed="Ra9ce4438637b4dba"/>
+          <a:blip xmlns:r="http://schemas.openxmlformats.org/officeDocument/2006/relationships" xmlns:a="http://schemas.openxmlformats.org/drawingml/2006/main" r:embed="Rf8d2fa69f9f847c6"/>
           <a:stretch xmlns:a="http://schemas.openxmlformats.org/drawingml/2006/main">
             <a:fillRect l="0" t="0" r="0" b="0"/>
           </a:stretch>
@@ -6652,7 +6646,7 @@
                 <a:ea typeface="微软雅黑"/>
                 <a:cs typeface="微软雅黑"/>
               </a:rPr>
-              <a:t>2. 下一阶段</a:t>
+              <a:t>2. 落地计划</a:t>
             </a:r>
             <a:endParaRPr>
               <a:latin typeface="微软雅黑"/>
@@ -6676,7 +6670,7 @@
                 <a:ea typeface="微软雅黑"/>
                 <a:cs typeface="微软雅黑"/>
               </a:rPr>
-              <a:t>P1：C1 / C4 / C6 跨刀具泛化与域适配</a:t>
+              <a:t>P1：C1 / C4 / C6 跨刀具泛化、域适配与复赛部署</a:t>
             </a:r>
             <a:endParaRPr>
               <a:latin typeface="微软雅黑"/>
@@ -6695,7 +6689,7 @@
               <a:buChar char="•"/>
             </a:pPr>
             <a:r>
-              <a:t/>
+              <a:t>3. 产品化路线</a:t>
             </a:r>
             <a:endParaRPr>
               <a:latin typeface="微软雅黑"/>
@@ -6719,7 +6713,7 @@
                 <a:ea typeface="微软雅黑"/>
                 <a:cs typeface="微软雅黑"/>
               </a:rPr>
-              <a:t>3. 产品化路线</a:t>
+              <a:t>P1.5：VB 回归、注意力和多分支融合</a:t>
             </a:r>
             <a:endParaRPr>
               <a:latin typeface="微软雅黑"/>
@@ -6743,31 +6737,7 @@
                 <a:ea typeface="微软雅黑"/>
                 <a:cs typeface="微软雅黑"/>
               </a:rPr>
-              <a:t>P1.5：VB 回归、注意力和多分支融合</a:t>
-            </a:r>
-            <a:endParaRPr>
-              <a:latin typeface="微软雅黑"/>
-              <a:ea typeface="微软雅黑"/>
-              <a:cs typeface="微软雅黑"/>
-            </a:endParaRPr>
-          </a:p>
-          <a:p xmlns:a="http://schemas.openxmlformats.org/drawingml/2006/main">
-            <a:pPr marL="285750" indent="-285750" algn="l">
-              <a:lnSpc>
-                <a:spcPct val="150000"/>
-              </a:lnSpc>
-              <a:buClrTx/>
-              <a:buSzTx/>
-              <a:buFont typeface="Arial"/>
-              <a:buChar char="•"/>
-            </a:pPr>
-            <a:r>
-              <a:rPr>
-                <a:latin typeface="微软雅黑"/>
-                <a:ea typeface="微软雅黑"/>
-                <a:cs typeface="微软雅黑"/>
-              </a:rPr>
-              <a:t>P2：企业数据接入、RAG、观测、回滚与权限治理</a:t>
+              <a:t>P2：企业数据接入、RAG、观测、回滚、权限治理与 MCP 适配</a:t>
             </a:r>
             <a:endParaRPr>
               <a:latin typeface="微软雅黑"/>
@@ -10029,7 +9999,7 @@
           <p:nvPr/>
         </p:nvPicPr>
         <p:blipFill>
-          <a:blip xmlns:r="http://schemas.openxmlformats.org/officeDocument/2006/relationships" xmlns:a="http://schemas.openxmlformats.org/drawingml/2006/main" r:embed="R4f380b33f2914aa3"/>
+          <a:blip xmlns:r="http://schemas.openxmlformats.org/officeDocument/2006/relationships" xmlns:a="http://schemas.openxmlformats.org/drawingml/2006/main" r:embed="Rdbd287db28fd45cd"/>
           <a:stretch xmlns:a="http://schemas.openxmlformats.org/drawingml/2006/main">
             <a:fillRect l="0" t="0" r="0" b="0"/>
           </a:stretch>
@@ -10093,7 +10063,7 @@
           <p:nvPr/>
         </p:nvPicPr>
         <p:blipFill>
-          <a:blip xmlns:r="http://schemas.openxmlformats.org/officeDocument/2006/relationships" xmlns:a="http://schemas.openxmlformats.org/drawingml/2006/main" r:embed="R1e0d6c404fd54f55"/>
+          <a:blip xmlns:r="http://schemas.openxmlformats.org/officeDocument/2006/relationships" xmlns:a="http://schemas.openxmlformats.org/drawingml/2006/main" r:embed="R1e6872f55ba54bb2"/>
           <a:stretch xmlns:a="http://schemas.openxmlformats.org/drawingml/2006/main">
             <a:fillRect l="0" t="0" r="0" b="0"/>
           </a:stretch>
@@ -10466,7 +10436,7 @@
         <p:spPr>
           <a:xfrm xmlns:a="http://schemas.openxmlformats.org/drawingml/2006/main">
             <a:off x="525780" y="1204595"/>
-            <a:ext cx="8013065" cy="640080"/>
+            <a:ext cx="8013065" cy="914400"/>
           </a:xfrm>
           <a:prstGeom xmlns:a="http://schemas.openxmlformats.org/drawingml/2006/main" prst="rect">
             <a:avLst/>
@@ -10485,7 +10455,7 @@
                 <a:ea typeface="微软雅黑"/>
                 <a:cs typeface="微软雅黑"/>
               </a:rPr>
-              <a:t>定义 → 数据准备 → 候选 → 审批 → 训练 → 评估 → 决策归档；状态、代码、图表和 Evidence 共用同一 trace。</a:t>
+              <a:t>主控拆解任务 → Agent 按职责执行 → ExperimentState / PipelineSpec / EvidenceRef 传递上下文 → validation 验证 → 失败重试、换方案或停止 → Trace 归档。</a:t>
             </a:r>
             <a:endParaRPr>
               <a:latin typeface="微软雅黑"/>
@@ -10504,7 +10474,7 @@
           <p:nvPr/>
         </p:nvPicPr>
         <p:blipFill>
-          <a:blip xmlns:r="http://schemas.openxmlformats.org/officeDocument/2006/relationships" xmlns:a="http://schemas.openxmlformats.org/drawingml/2006/main" r:embed="R6c522b1e2fcb4c35"/>
+          <a:blip xmlns:r="http://schemas.openxmlformats.org/officeDocument/2006/relationships" xmlns:a="http://schemas.openxmlformats.org/drawingml/2006/main" r:embed="R10c240a63b554b78"/>
           <a:stretch xmlns:a="http://schemas.openxmlformats.org/drawingml/2006/main">
             <a:fillRect l="0" t="0" r="0" b="0"/>
           </a:stretch>
@@ -11045,7 +11015,7 @@
                 <a:ea typeface="微软雅黑"/>
                 <a:cs typeface="微软雅黑"/>
               </a:rPr>
-              <a:t>主控拆解任务；五个 Worker 只调用获授权 Skill。一次 Registry 输入缺失被策略拒绝，补齐后重试成功。</a:t>
+              <a:t>主控拆解任务；Worker 以 experiment、revision、trace 和 EvidenceRef 交接上下文。Registry 输入缺失会被拒绝，补齐后有限重试。</a:t>
             </a:r>
             <a:endParaRPr>
               <a:latin typeface="微软雅黑"/>
@@ -11064,7 +11034,7 @@
           <p:nvPr/>
         </p:nvPicPr>
         <p:blipFill>
-          <a:blip xmlns:r="http://schemas.openxmlformats.org/officeDocument/2006/relationships" xmlns:a="http://schemas.openxmlformats.org/drawingml/2006/main" r:embed="R6cabe52e99a740ce"/>
+          <a:blip xmlns:r="http://schemas.openxmlformats.org/officeDocument/2006/relationships" xmlns:a="http://schemas.openxmlformats.org/drawingml/2006/main" r:embed="Rbcb5b7666dd34d2b"/>
           <a:stretch xmlns:a="http://schemas.openxmlformats.org/drawingml/2006/main">
             <a:fillRect l="0" t="0" r="0" b="0"/>
           </a:stretch>
@@ -11088,7 +11058,7 @@
           <p:nvPr/>
         </p:nvPicPr>
         <p:blipFill>
-          <a:blip xmlns:r="http://schemas.openxmlformats.org/officeDocument/2006/relationships" xmlns:a="http://schemas.openxmlformats.org/drawingml/2006/main" r:embed="Rbd26e5778696450d"/>
+          <a:blip xmlns:r="http://schemas.openxmlformats.org/officeDocument/2006/relationships" xmlns:a="http://schemas.openxmlformats.org/drawingml/2006/main" r:embed="R63c40153c6fd4191"/>
           <a:stretch xmlns:a="http://schemas.openxmlformats.org/drawingml/2006/main">
             <a:fillRect l="0" t="0" r="0" b="0"/>
           </a:stretch>

</xml_diff>